<commit_message>
Slide rielaborate con Bussola internazionale 2026 e timeline del percorso
Ogni deck chiude con la slide Bussola internazionale della tappa; integrati
nei contenuti i dati TALIS 2024, Bender, Common Sense, Tutor CoPilot,
metacognitive laziness, Vaccaro, categorie TVET con non-delegable anchor,
MOOC UNESCO e Digital Learning Week. Timeline formalizzata con le
correzioni (GEM come lente di equita', ghost learners riformulato).

Co-Authored-By: Claude Fable 5 <noreply@anthropic.com>
Claude-Session: https://claude.ai/code/session_0172uWTkaEwfthdZ7KpLdiL5
</commit_message>
<xml_diff>
--- a/progetto-snodi/corsi/edu-genai-2/incontri/01-ambiente-protetto.pptx
+++ b/progetto-snodi/corsi/edu-genai-2/incontri/01-ambiente-protetto.pptx
@@ -15,9 +15,10 @@
     <p:sldId id="263" r:id="rId9"/>
     <p:sldId id="264" r:id="rId10"/>
     <p:sldId id="265" r:id="rId11"/>
+    <p:sldId id="266" r:id="rId12"/>
   </p:sldIdLst>
   <p:notesMasterIdLst>
-    <p:notesMasterId r:id="rId12"/>
+    <p:notesMasterId r:id="rId13"/>
   </p:notesMasterIdLst>
   <p:sldSz cx="12188952" cy="6858000"/>
   <p:notesSz cx="6858000" cy="12188952"/>
@@ -599,7 +600,7 @@
           <a:p>
             <a:r>
               <a:rPr lang="en-US" dirty="0"/>
-              <a:t>Chiudere puntuali alle 18. Ricordare firma del registro presenze. Il materiale da portare per l'incontro 2 è essenziale: ci lavoreranno sopra.</a:t>
+              <a:t>Slide-firma della serie: ogni incontro chiude con la bussola internazionale della tappa. Messaggio: quello che facciamo qui è allineato agli indirizzi UNESCO/OCSE 2026, non improvvisazione locale. Sulla citazione §104: è la frase da riprendere all'incontro 4 e 5.</a:t>
             </a:r>
             <a:endParaRPr lang="en-US" dirty="0"/>
           </a:p>
@@ -623,6 +624,94 @@
             <a:fld id="{F7021451-1387-4CA6-816F-3879F97B5CBC}" type="slidenum">
               <a:rPr lang="en-US"/>
               <a:t>10</a:t>
+            </a:fld>
+            <a:endParaRPr lang="en-US"/>
+          </a:p>
+        </p:txBody>
+      </p:sp>
+    </p:spTree>
+    <p:extLst>
+      <p:ext uri="{BB962C8B-B14F-4D97-AF65-F5344CB8AC3E}">
+        <p14:creationId xmlns:p14="http://schemas.microsoft.com/office/powerpoint/2010/main" val="1024086991"/>
+      </p:ext>
+    </p:extLst>
+  </p:cSld>
+  <p:clrMapOvr>
+    <a:masterClrMapping/>
+  </p:clrMapOvr>
+</p:notes>
+</file>
+
+<file path=ppt/notesSlides/notesSlide11.xml><?xml version="1.0" encoding="utf-8"?>
+<p:notes xmlns:a="http://schemas.openxmlformats.org/drawingml/2006/main" xmlns:r="http://schemas.openxmlformats.org/officeDocument/2006/relationships" xmlns:p="http://schemas.openxmlformats.org/presentationml/2006/main">
+  <p:cSld>
+    <p:spTree>
+      <p:nvGrpSpPr>
+        <p:cNvPr id="1" name=""/>
+        <p:cNvGrpSpPr/>
+        <p:nvPr/>
+      </p:nvGrpSpPr>
+      <p:grpSpPr>
+        <a:xfrm>
+          <a:off x="0" y="0"/>
+          <a:ext cx="0" cy="0"/>
+          <a:chOff x="0" y="0"/>
+          <a:chExt cx="0" cy="0"/>
+        </a:xfrm>
+      </p:grpSpPr>
+      <p:sp>
+        <p:nvSpPr>
+          <p:cNvPr id="2" name="Slide Image Placeholder 1"/>
+          <p:cNvSpPr>
+            <a:spLocks noGrp="1" noRot="1" noChangeAspect="1"/>
+          </p:cNvSpPr>
+          <p:nvPr>
+            <p:ph type="sldImg"/>
+          </p:nvPr>
+        </p:nvSpPr>
+        <p:spPr/>
+      </p:sp>
+      <p:sp>
+        <p:nvSpPr>
+          <p:cNvPr id="3" name="Notes Placeholder 2"/>
+          <p:cNvSpPr>
+            <a:spLocks noGrp="1"/>
+          </p:cNvSpPr>
+          <p:nvPr>
+            <p:ph type="body" idx="1"/>
+          </p:nvPr>
+        </p:nvSpPr>
+        <p:spPr/>
+        <p:txBody>
+          <a:bodyPr/>
+          <a:lstStyle/>
+          <a:p>
+            <a:r>
+              <a:rPr lang="en-US" dirty="0"/>
+              <a:t>Chiudere puntuali alle 18. Ricordare firma del registro presenze. Il materiale da portare per l'incontro 2 è essenziale: ci lavoreranno sopra.</a:t>
+            </a:r>
+            <a:endParaRPr lang="en-US" dirty="0"/>
+          </a:p>
+        </p:txBody>
+      </p:sp>
+      <p:sp>
+        <p:nvSpPr>
+          <p:cNvPr id="4" name="Slide Number Placeholder 3"/>
+          <p:cNvSpPr>
+            <a:spLocks noGrp="1"/>
+          </p:cNvSpPr>
+          <p:nvPr>
+            <p:ph type="sldNum" sz="quarter" idx="10"/>
+          </p:nvPr>
+        </p:nvSpPr>
+        <p:spPr/>
+        <p:txBody>
+          <a:bodyPr/>
+          <a:lstStyle/>
+          <a:p>
+            <a:fld id="{F7021451-1387-4CA6-816F-3879F97B5CBC}" type="slidenum">
+              <a:rPr lang="en-US"/>
+              <a:t>11</a:t>
             </a:fld>
             <a:endParaRPr lang="en-US"/>
           </a:p>
@@ -775,7 +864,7 @@
           <a:p>
             <a:r>
               <a:rPr lang="en-US" dirty="0"/>
-              <a:t>Dato INDIRE per legittimare i presenti: metà aula probabilmente usa già ChatGPT o Gemini. Non è un corso per principianti assoluti né per esperti: è un corso per professionisti che vogliono metodo. Citare la sperimentazione ministeriale per collocare lo Snodo nel quadro nazionale.</a:t>
+              <a:t>Dato INDIRE per legittimare i presenti; TALIS 2024 per legittimare il corso (il 75% che si sente impreparato). Il dato studenti (Estonia 90%, Svizzera ~50% settimanale) sposta la domanda: non 'se' ma 'come'. Citare la sperimentazione ministeriale per collocare lo Snodo nel quadro nazionale.</a:t>
             </a:r>
             <a:endParaRPr lang="en-US" dirty="0"/>
           </a:p>
@@ -863,7 +952,7 @@
           <a:p>
             <a:r>
               <a:rPr lang="en-US" dirty="0"/>
-              <a:t>Livello divulgativo ma rigoroso: niente matematica, ma il concetto di predizione probabilistica deve passare. La frase chiave da far segnare: fluidità non è affidabilità. Chiedere: quante volte vi è capitato un riferimento bibliografico inventato? Aggancio alla prossima slide.</a:t>
+              <a:t>Livello divulgativo ma rigoroso: niente matematica, ma il concetto di predizione probabilistica deve passare. La frase chiave da far segnare: fluidità non è affidabilità. La citazione di Bender (dall'antologia UNESCO 2025) chiude il punto: gli LLM accedono alla forma del linguaggio, non al significato. Chiedere: quante volte vi è capitato un riferimento bibliografico inventato?</a:t>
             </a:r>
             <a:endParaRPr lang="en-US" dirty="0"/>
           </a:p>
@@ -1966,6 +2055,416 @@
     <p:bg>
       <p:bgPr>
         <a:solidFill>
+          <a:srgbClr val="FFFFFF"/>
+        </a:solidFill>
+      </p:bgPr>
+    </p:bg>
+    <p:spTree>
+      <p:nvGrpSpPr>
+        <p:cNvPr id="1" name=""/>
+        <p:cNvGrpSpPr/>
+        <p:nvPr/>
+      </p:nvGrpSpPr>
+      <p:grpSpPr>
+        <a:xfrm>
+          <a:off x="0" y="0"/>
+          <a:ext cx="0" cy="0"/>
+          <a:chOff x="0" y="0"/>
+          <a:chExt cx="0" cy="0"/>
+        </a:xfrm>
+      </p:grpSpPr>
+      <p:sp>
+        <p:nvSpPr>
+          <p:cNvPr id="2" name="Shape 0"/>
+          <p:cNvSpPr/>
+          <p:nvPr/>
+        </p:nvSpPr>
+        <p:spPr>
+          <a:xfrm>
+            <a:off x="502920" y="384048"/>
+            <a:ext cx="566928" cy="566928"/>
+          </a:xfrm>
+          <a:prstGeom prst="ellipse">
+            <a:avLst/>
+          </a:prstGeom>
+          <a:solidFill>
+            <a:srgbClr val="1E2761"/>
+          </a:solidFill>
+          <a:ln w="12700">
+            <a:solidFill>
+              <a:srgbClr val="1E2761"/>
+            </a:solidFill>
+            <a:prstDash val="solid"/>
+          </a:ln>
+        </p:spPr>
+      </p:sp>
+      <p:sp>
+        <p:nvSpPr>
+          <p:cNvPr id="3" name="Text 1"/>
+          <p:cNvSpPr/>
+          <p:nvPr/>
+        </p:nvSpPr>
+        <p:spPr>
+          <a:xfrm>
+            <a:off x="502920" y="384048"/>
+            <a:ext cx="566928" cy="566928"/>
+          </a:xfrm>
+          <a:prstGeom prst="rect">
+            <a:avLst/>
+          </a:prstGeom>
+          <a:noFill/>
+          <a:ln/>
+        </p:spPr>
+        <p:txBody>
+          <a:bodyPr wrap="square" lIns="0" tIns="0" rIns="0" bIns="0" rtlCol="0" anchor="ctr"/>
+          <a:lstStyle/>
+          <a:p>
+            <a:pPr algn="ctr" indent="0" marL="0">
+              <a:buNone/>
+            </a:pPr>
+            <a:r>
+              <a:rPr lang="en-US" sz="1800" b="1" dirty="0">
+                <a:solidFill>
+                  <a:srgbClr val="FFFFFF"/>
+                </a:solidFill>
+                <a:latin typeface="Cambria" pitchFamily="34" charset="0"/>
+                <a:ea typeface="Cambria" pitchFamily="34" charset="-122"/>
+                <a:cs typeface="Cambria" pitchFamily="34" charset="-120"/>
+              </a:rPr>
+              <a:t>1</a:t>
+            </a:r>
+            <a:endParaRPr lang="en-US" sz="1800" dirty="0"/>
+          </a:p>
+        </p:txBody>
+      </p:sp>
+      <p:sp>
+        <p:nvSpPr>
+          <p:cNvPr id="4" name="Text 2"/>
+          <p:cNvSpPr/>
+          <p:nvPr/>
+        </p:nvSpPr>
+        <p:spPr>
+          <a:xfrm>
+            <a:off x="1234440" y="347472"/>
+            <a:ext cx="9601200" cy="274320"/>
+          </a:xfrm>
+          <a:prstGeom prst="rect">
+            <a:avLst/>
+          </a:prstGeom>
+          <a:noFill/>
+          <a:ln/>
+        </p:spPr>
+        <p:txBody>
+          <a:bodyPr wrap="square" lIns="0" tIns="0" rIns="0" bIns="0" rtlCol="0" anchor="ctr"/>
+          <a:lstStyle/>
+          <a:p>
+            <a:pPr indent="0" marL="0">
+              <a:buNone/>
+            </a:pPr>
+            <a:r>
+              <a:rPr lang="en-US" sz="1100" dirty="0">
+                <a:solidFill>
+                  <a:srgbClr val="5B6B7C"/>
+                </a:solidFill>
+                <a:latin typeface="Calibri" pitchFamily="34" charset="0"/>
+                <a:ea typeface="Calibri" pitchFamily="34" charset="-122"/>
+                <a:cs typeface="Calibri" pitchFamily="34" charset="-120"/>
+              </a:rPr>
+              <a:t>Edu-GenAI 2 — Didattica Aumentata e Data Literacy</a:t>
+            </a:r>
+            <a:endParaRPr lang="en-US" sz="1100" dirty="0"/>
+          </a:p>
+        </p:txBody>
+      </p:sp>
+      <p:sp>
+        <p:nvSpPr>
+          <p:cNvPr id="5" name="Text 3"/>
+          <p:cNvSpPr/>
+          <p:nvPr/>
+        </p:nvSpPr>
+        <p:spPr>
+          <a:xfrm>
+            <a:off x="1234440" y="566928"/>
+            <a:ext cx="10332720" cy="685800"/>
+          </a:xfrm>
+          <a:prstGeom prst="rect">
+            <a:avLst/>
+          </a:prstGeom>
+          <a:noFill/>
+          <a:ln/>
+        </p:spPr>
+        <p:txBody>
+          <a:bodyPr wrap="square" lIns="0" tIns="0" rIns="0" bIns="0" rtlCol="0" anchor="ctr"/>
+          <a:lstStyle/>
+          <a:p>
+            <a:pPr indent="0" marL="0">
+              <a:buNone/>
+            </a:pPr>
+            <a:r>
+              <a:rPr lang="en-US" sz="3000" b="1" dirty="0">
+                <a:solidFill>
+                  <a:srgbClr val="1E2761"/>
+                </a:solidFill>
+                <a:latin typeface="Cambria" pitchFamily="34" charset="0"/>
+                <a:ea typeface="Cambria" pitchFamily="34" charset="-122"/>
+                <a:cs typeface="Cambria" pitchFamily="34" charset="-120"/>
+              </a:rPr>
+              <a:t>Bussola internazionale 2026</a:t>
+            </a:r>
+            <a:endParaRPr lang="en-US" sz="3000" dirty="0"/>
+          </a:p>
+        </p:txBody>
+      </p:sp>
+      <p:sp>
+        <p:nvSpPr>
+          <p:cNvPr id="6" name="Text 4"/>
+          <p:cNvSpPr/>
+          <p:nvPr/>
+        </p:nvSpPr>
+        <p:spPr>
+          <a:xfrm>
+            <a:off x="822960" y="1600200"/>
+            <a:ext cx="6492240" cy="4754880"/>
+          </a:xfrm>
+          <a:prstGeom prst="rect">
+            <a:avLst/>
+          </a:prstGeom>
+          <a:noFill/>
+          <a:ln/>
+        </p:spPr>
+        <p:txBody>
+          <a:bodyPr wrap="square" lIns="0" tIns="0" rIns="0" bIns="0" rtlCol="0" anchor="t"/>
+          <a:lstStyle/>
+          <a:p>
+            <a:pPr marL="177800" indent="-177800">
+              <a:spcAft>
+                <a:spcPts val="800"/>
+              </a:spcAft>
+              <a:buSzPct val="100000"/>
+              <a:buChar char="•"/>
+            </a:pPr>
+            <a:r>
+              <a:rPr lang="en-US" sz="1500" b="1" dirty="0">
+                <a:solidFill>
+                  <a:srgbClr val="26303B"/>
+                </a:solidFill>
+                <a:latin typeface="Calibri" pitchFamily="34" charset="0"/>
+                <a:ea typeface="Calibri" pitchFamily="34" charset="-122"/>
+                <a:cs typeface="Calibri" pitchFamily="34" charset="-120"/>
+              </a:rPr>
+              <a:t>UNESCO — Transforming Higher Education (2026): l'approccio rigorosamente antropocentrico — la scuola insegna ad «allocare attenzione e sforzo» nell'abbondanza informativa</a:t>
+            </a:r>
+            <a:endParaRPr lang="en-US" sz="1500" dirty="0"/>
+          </a:p>
+          <a:p>
+            <a:pPr marL="177800" indent="-177800">
+              <a:spcAft>
+                <a:spcPts val="800"/>
+              </a:spcAft>
+              <a:buSzPct val="100000"/>
+              <a:buChar char="•"/>
+            </a:pPr>
+            <a:r>
+              <a:rPr lang="en-US" sz="1500" dirty="0">
+                <a:solidFill>
+                  <a:srgbClr val="26303B"/>
+                </a:solidFill>
+                <a:latin typeface="Calibri" pitchFamily="34" charset="0"/>
+                <a:ea typeface="Calibri" pitchFamily="34" charset="-122"/>
+                <a:cs typeface="Calibri" pitchFamily="34" charset="-120"/>
+              </a:rPr>
+              <a:t>UNESCO IICBA/ICHEI — Digitalization in Africa (2026): l'integrazione dell'IA regge solo su un ecosistema istituzionale solido (team dedicati, formazione, supporto) — è la ragione d'essere dello Snodo</a:t>
+            </a:r>
+            <a:endParaRPr lang="en-US" sz="1500" dirty="0"/>
+          </a:p>
+          <a:p>
+            <a:pPr marL="177800" indent="-177800">
+              <a:spcAft>
+                <a:spcPts val="800"/>
+              </a:spcAft>
+              <a:buSzPct val="100000"/>
+              <a:buChar char="•"/>
+            </a:pPr>
+            <a:r>
+              <a:rPr lang="en-US" sz="1500" dirty="0">
+                <a:solidFill>
+                  <a:srgbClr val="26303B"/>
+                </a:solidFill>
+                <a:latin typeface="Calibri" pitchFamily="34" charset="0"/>
+                <a:ea typeface="Calibri" pitchFamily="34" charset="-122"/>
+                <a:cs typeface="Calibri" pitchFamily="34" charset="-120"/>
+              </a:rPr>
+              <a:t>Raccomandazione UNESCO sull'etica dell'IA (2021, §104): «AI should support the learning process without reducing cognitive abilities» — la missione di questo corso in una riga</a:t>
+            </a:r>
+            <a:endParaRPr lang="en-US" sz="1500" dirty="0"/>
+          </a:p>
+        </p:txBody>
+      </p:sp>
+      <p:sp>
+        <p:nvSpPr>
+          <p:cNvPr id="7" name="Shape 5"/>
+          <p:cNvSpPr/>
+          <p:nvPr/>
+        </p:nvSpPr>
+        <p:spPr>
+          <a:xfrm>
+            <a:off x="7635240" y="1600200"/>
+            <a:ext cx="3977640" cy="4480560"/>
+          </a:xfrm>
+          <a:prstGeom prst="roundRect">
+            <a:avLst>
+              <a:gd name="adj" fmla="val 2069"/>
+            </a:avLst>
+          </a:prstGeom>
+          <a:solidFill>
+            <a:srgbClr val="E9F1FB"/>
+          </a:solidFill>
+          <a:ln w="12700">
+            <a:solidFill>
+              <a:srgbClr val="E9F1FB"/>
+            </a:solidFill>
+            <a:prstDash val="solid"/>
+          </a:ln>
+        </p:spPr>
+      </p:sp>
+      <p:sp>
+        <p:nvSpPr>
+          <p:cNvPr id="8" name="Text 6"/>
+          <p:cNvSpPr/>
+          <p:nvPr/>
+        </p:nvSpPr>
+        <p:spPr>
+          <a:xfrm>
+            <a:off x="7863840" y="1764792"/>
+            <a:ext cx="3520440" cy="320040"/>
+          </a:xfrm>
+          <a:prstGeom prst="rect">
+            <a:avLst/>
+          </a:prstGeom>
+          <a:noFill/>
+          <a:ln/>
+        </p:spPr>
+        <p:txBody>
+          <a:bodyPr wrap="square" lIns="0" tIns="0" rIns="0" bIns="0" rtlCol="0" anchor="ctr"/>
+          <a:lstStyle/>
+          <a:p>
+            <a:pPr indent="0" marL="0">
+              <a:buNone/>
+            </a:pPr>
+            <a:r>
+              <a:rPr lang="en-US" sz="1450" b="1" dirty="0">
+                <a:solidFill>
+                  <a:srgbClr val="1E2761"/>
+                </a:solidFill>
+                <a:latin typeface="Cambria" pitchFamily="34" charset="0"/>
+                <a:ea typeface="Cambria" pitchFamily="34" charset="-122"/>
+                <a:cs typeface="Cambria" pitchFamily="34" charset="-120"/>
+              </a:rPr>
+              <a:t>Perché ve lo mostriamo</a:t>
+            </a:r>
+            <a:endParaRPr lang="en-US" sz="1450" dirty="0"/>
+          </a:p>
+        </p:txBody>
+      </p:sp>
+      <p:sp>
+        <p:nvSpPr>
+          <p:cNvPr id="9" name="Text 7"/>
+          <p:cNvSpPr/>
+          <p:nvPr/>
+        </p:nvSpPr>
+        <p:spPr>
+          <a:xfrm>
+            <a:off x="7863840" y="2130552"/>
+            <a:ext cx="3520440" cy="3794760"/>
+          </a:xfrm>
+          <a:prstGeom prst="rect">
+            <a:avLst/>
+          </a:prstGeom>
+          <a:noFill/>
+          <a:ln/>
+        </p:spPr>
+        <p:txBody>
+          <a:bodyPr wrap="square" lIns="0" tIns="0" rIns="0" bIns="0" rtlCol="0" anchor="t"/>
+          <a:lstStyle/>
+          <a:p>
+            <a:pPr marL="152400" indent="-152400">
+              <a:spcAft>
+                <a:spcPts val="500"/>
+              </a:spcAft>
+              <a:buSzPct val="100000"/>
+              <a:buChar char="•"/>
+            </a:pPr>
+            <a:r>
+              <a:rPr lang="en-US" sz="1250" dirty="0">
+                <a:solidFill>
+                  <a:srgbClr val="26303B"/>
+                </a:solidFill>
+                <a:latin typeface="Calibri" pitchFamily="34" charset="0"/>
+                <a:ea typeface="Calibri" pitchFamily="34" charset="-122"/>
+                <a:cs typeface="Calibri" pitchFamily="34" charset="-120"/>
+              </a:rPr>
+              <a:t>Il corso non è un'iniziativa locale: attua indirizzi internazionali convergenti</a:t>
+            </a:r>
+            <a:endParaRPr lang="en-US" sz="1250" dirty="0"/>
+          </a:p>
+          <a:p>
+            <a:pPr marL="152400" indent="-152400">
+              <a:spcAft>
+                <a:spcPts val="500"/>
+              </a:spcAft>
+              <a:buSzPct val="100000"/>
+              <a:buChar char="•"/>
+            </a:pPr>
+            <a:r>
+              <a:rPr lang="en-US" sz="1250" dirty="0">
+                <a:solidFill>
+                  <a:srgbClr val="26303B"/>
+                </a:solidFill>
+                <a:latin typeface="Calibri" pitchFamily="34" charset="0"/>
+                <a:ea typeface="Calibri" pitchFamily="34" charset="-122"/>
+                <a:cs typeface="Calibri" pitchFamily="34" charset="-120"/>
+              </a:rPr>
+              <a:t>Antropocentrismo = stesso principio del DM 166/2025</a:t>
+            </a:r>
+            <a:endParaRPr lang="en-US" sz="1250" dirty="0"/>
+          </a:p>
+          <a:p>
+            <a:pPr marL="152400" indent="-152400">
+              <a:spcAft>
+                <a:spcPts val="500"/>
+              </a:spcAft>
+              <a:buSzPct val="100000"/>
+              <a:buChar char="•"/>
+            </a:pPr>
+            <a:r>
+              <a:rPr lang="en-US" sz="1250" b="1" dirty="0">
+                <a:solidFill>
+                  <a:srgbClr val="26303B"/>
+                </a:solidFill>
+                <a:latin typeface="Calibri" pitchFamily="34" charset="0"/>
+                <a:ea typeface="Calibri" pitchFamily="34" charset="-122"/>
+                <a:cs typeface="Calibri" pitchFamily="34" charset="-120"/>
+              </a:rPr>
+              <a:t>Ogni incontro chiude con la sua bussola</a:t>
+            </a:r>
+            <a:endParaRPr lang="en-US" sz="1250" dirty="0"/>
+          </a:p>
+        </p:txBody>
+      </p:sp>
+    </p:spTree>
+  </p:cSld>
+  <p:clrMapOvr>
+    <a:masterClrMapping/>
+  </p:clrMapOvr>
+</p:sld>
+</file>
+
+<file path=ppt/slides/slide11.xml><?xml version="1.0" encoding="utf-8"?>
+<p:sld xmlns:a="http://schemas.openxmlformats.org/drawingml/2006/main" xmlns:r="http://schemas.openxmlformats.org/officeDocument/2006/relationships" xmlns:p="http://schemas.openxmlformats.org/presentationml/2006/main">
+  <p:cSld name="Slide 11">
+    <p:bg>
+      <p:bgPr>
+        <a:solidFill>
           <a:srgbClr val="1E2761"/>
         </a:solidFill>
       </p:bgPr>
@@ -3764,7 +4263,7 @@
                 <a:ea typeface="Calibri" pitchFamily="34" charset="-122"/>
                 <a:cs typeface="Calibri" pitchFamily="34" charset="-120"/>
               </a:rPr>
-              <a:t>Sperimentazione MIM 2024-26 in 4 regioni, valutazione INVALSI in corso</a:t>
+              <a:t>OCSE TALIS 2024: il 36% dei docenti ha usato l'IA nell'ultimo anno — ma 3 su 4 si dichiarano impreparati a insegnarci. Questo corso esiste per quel 75%</a:t>
             </a:r>
             <a:endParaRPr lang="en-US" sz="1500" dirty="0"/>
           </a:p>
@@ -3785,7 +4284,28 @@
                 <a:ea typeface="Calibri" pitchFamily="34" charset="-122"/>
                 <a:cs typeface="Calibri" pitchFamily="34" charset="-120"/>
               </a:rPr>
-              <a:t>Lo Snodo Volterra: 6 percorsi per il personale + 25 laboratori con gli studenti</a:t>
+              <a:t>E gli studenti sono più avanti di noi: in Estonia il 90% del secondo ciclo usa la GenAI per studiare (OECD Outlook 2026)</a:t>
+            </a:r>
+            <a:endParaRPr lang="en-US" sz="1500" dirty="0"/>
+          </a:p>
+          <a:p>
+            <a:pPr marL="177800" indent="-177800">
+              <a:spcAft>
+                <a:spcPts val="800"/>
+              </a:spcAft>
+              <a:buSzPct val="100000"/>
+              <a:buChar char="•"/>
+            </a:pPr>
+            <a:r>
+              <a:rPr lang="en-US" sz="1500" dirty="0">
+                <a:solidFill>
+                  <a:srgbClr val="26303B"/>
+                </a:solidFill>
+                <a:latin typeface="Calibri" pitchFamily="34" charset="0"/>
+                <a:ea typeface="Calibri" pitchFamily="34" charset="-122"/>
+                <a:cs typeface="Calibri" pitchFamily="34" charset="-120"/>
+              </a:rPr>
+              <a:t>Sperimentazione MIM 2024-26 in 4 regioni, valutazione INVALSI in corso</a:t>
             </a:r>
             <a:endParaRPr lang="en-US" sz="1500" dirty="0"/>
           </a:p>
@@ -4279,6 +4799,26 @@
             </a:r>
             <a:endParaRPr lang="en-US" sz="1250" dirty="0"/>
           </a:p>
+          <a:p>
+            <a:pPr indent="0" marL="0">
+              <a:spcAft>
+                <a:spcPts val="500"/>
+              </a:spcAft>
+              <a:buNone/>
+            </a:pPr>
+            <a:r>
+              <a:rPr lang="en-US" sz="1250" dirty="0">
+                <a:solidFill>
+                  <a:srgbClr val="26303B"/>
+                </a:solidFill>
+                <a:latin typeface="Calibri" pitchFamily="34" charset="0"/>
+                <a:ea typeface="Calibri" pitchFamily="34" charset="-122"/>
+                <a:cs typeface="Calibri" pitchFamily="34" charset="-120"/>
+              </a:rPr>
+              <a:t>«L'intelligenza che percepiamo è una proiezione della nostra» — E. Bender (UNESCO 2025)</a:t>
+            </a:r>
+            <a:endParaRPr lang="en-US" sz="1250" dirty="0"/>
+          </a:p>
         </p:txBody>
       </p:sp>
     </p:spTree>
@@ -5285,6 +5825,27 @@
                 <a:cs typeface="Calibri" pitchFamily="34" charset="-120"/>
               </a:rPr>
               <a:t>DPIA d'istituto: gli strumenti censiti sono questi</a:t>
+            </a:r>
+            <a:endParaRPr lang="en-US" sz="1250" dirty="0"/>
+          </a:p>
+          <a:p>
+            <a:pPr marL="152400" indent="-152400">
+              <a:spcAft>
+                <a:spcPts val="500"/>
+              </a:spcAft>
+              <a:buSzPct val="100000"/>
+              <a:buChar char="•"/>
+            </a:pPr>
+            <a:r>
+              <a:rPr lang="en-US" sz="1250" dirty="0">
+                <a:solidFill>
+                  <a:srgbClr val="26303B"/>
+                </a:solidFill>
+                <a:latin typeface="Calibri" pitchFamily="34" charset="0"/>
+                <a:ea typeface="Calibri" pitchFamily="34" charset="-122"/>
+                <a:cs typeface="Calibri" pitchFamily="34" charset="-120"/>
+              </a:rPr>
+              <a:t>UNESCO 2025: solo il 20% di 150 prodotti ed-tech valutati supera gli standard minimi di privacy</a:t>
             </a:r>
             <a:endParaRPr lang="en-US" sz="1250" dirty="0"/>
           </a:p>

</xml_diff>